<commit_message>
Per-category SEBI benchmarks in deck + method-audit criticals fixed + FACTOR_NAVS.xlsx
Deck: every fund vs its own category benchmark (midcap = Midcap 150 TRI),
common-3y-window MDD labels, hybrid cushion split (vs BM / vs equity),
betas recalibrated to verified narratives; gates 0/0/0, republished.
Audit fixes: nav_monthend per-scheme upsert (weekend month-end bug; July
repaired 688 -> 8,504 schemes), backfill health-checked resume, adapter
fuzzy-match 85% bar + gap logging + staleness flags, skill texts (quadrant-4
catch-all, dual-framework "both at Sell, BUY vetoes", rank-over-all, PRI-vs-TRI
critical known-issue). FACTOR_NAVS.xlsx shipped (5,352 rows, Principal's column
order; AMFI extensions; house codes HDFC=9 Nippon=21) + 16th/29th auto-refresh
job. Escalations: PK=3 never-sells ruling; TRI rebuild before Oct-end;
Thursday stock run BLOCKED until 90/60 patch + pf_state reseed + feed refresh.

Co-Authored-By: Claude Fable 5 <noreply@anthropic.com>
</commit_message>
<xml_diff>
--- a/Shreyas_Ionic_AMC/09_PRODUCT/reports/NDPMS_Portfolio_Review_ABXY_RM_Lite.pptx
+++ b/Shreyas_Ionic_AMC/09_PRODUCT/reports/NDPMS_Portfolio_Review_ABXY_RM_Lite.pptx
@@ -8908,7 +8908,7 @@
                 </a:solidFill>
                 <a:latin typeface="Georgia"/>
               </a:rPr>
-              <a:t>MF sleeve only, Direct-plan NAV vs total-return benchmark · as of 2026-07-25</a:t>
+              <a:t>MF sleeve only, Direct-plan NAV, each scheme vs its own SEBI category benchmark (TRI) · as of 2026-07-25</a:t>
             </a:r>
           </a:p>
         </p:txBody>
@@ -9346,7 +9346,7 @@
         <p:spPr>
           <a:xfrm>
             <a:off x="7259576" y="2295144"/>
-            <a:ext cx="179222" cy="64008"/>
+            <a:ext cx="192024" cy="64008"/>
           </a:xfrm>
           <a:prstGeom prst="rect">
             <a:avLst/>
@@ -9462,7 +9462,7 @@
                 </a:solidFill>
                 <a:latin typeface="Bahnschrift"/>
               </a:rPr>
-              <a:t>28</a:t>
+              <a:t>30</a:t>
             </a:r>
           </a:p>
         </p:txBody>
@@ -9780,7 +9780,7 @@
         <p:spPr>
           <a:xfrm>
             <a:off x="7259576" y="2660904"/>
-            <a:ext cx="473659" cy="64008"/>
+            <a:ext cx="435254" cy="64008"/>
           </a:xfrm>
           <a:prstGeom prst="rect">
             <a:avLst/>
@@ -9896,7 +9896,7 @@
                 </a:solidFill>
                 <a:latin typeface="Bahnschrift"/>
               </a:rPr>
-              <a:t>74</a:t>
+              <a:t>68</a:t>
             </a:r>
           </a:p>
         </p:txBody>
@@ -10648,7 +10648,7 @@
         <p:spPr>
           <a:xfrm>
             <a:off x="7259576" y="3392424"/>
-            <a:ext cx="480060" cy="64008"/>
+            <a:ext cx="416052" cy="64008"/>
           </a:xfrm>
           <a:prstGeom prst="rect">
             <a:avLst/>
@@ -10764,7 +10764,7 @@
                 </a:solidFill>
                 <a:latin typeface="Bahnschrift"/>
               </a:rPr>
-              <a:t>75</a:t>
+              <a:t>65</a:t>
             </a:r>
           </a:p>
         </p:txBody>
@@ -11082,7 +11082,7 @@
         <p:spPr>
           <a:xfrm>
             <a:off x="7259576" y="3758184"/>
-            <a:ext cx="51206" cy="64008"/>
+            <a:ext cx="108813" cy="64008"/>
           </a:xfrm>
           <a:prstGeom prst="rect">
             <a:avLst/>
@@ -11198,7 +11198,7 @@
                 </a:solidFill>
                 <a:latin typeface="Bahnschrift"/>
               </a:rPr>
-              <a:t>8</a:t>
+              <a:t>17</a:t>
             </a:r>
           </a:p>
         </p:txBody>
@@ -11516,7 +11516,7 @@
         <p:spPr>
           <a:xfrm>
             <a:off x="7259576" y="4123944"/>
-            <a:ext cx="352044" cy="64008"/>
+            <a:ext cx="364845" cy="64008"/>
           </a:xfrm>
           <a:prstGeom prst="rect">
             <a:avLst/>
@@ -11632,7 +11632,7 @@
                 </a:solidFill>
                 <a:latin typeface="Bahnschrift"/>
               </a:rPr>
-              <a:t>55</a:t>
+              <a:t>57</a:t>
             </a:r>
           </a:p>
         </p:txBody>
@@ -11950,7 +11950,7 @@
         <p:spPr>
           <a:xfrm>
             <a:off x="7259576" y="4489704"/>
-            <a:ext cx="460857" cy="64008"/>
+            <a:ext cx="441655" cy="64008"/>
           </a:xfrm>
           <a:prstGeom prst="rect">
             <a:avLst/>
@@ -12066,7 +12066,7 @@
                 </a:solidFill>
                 <a:latin typeface="Bahnschrift"/>
               </a:rPr>
-              <a:t>72</a:t>
+              <a:t>69</a:t>
             </a:r>
           </a:p>
         </p:txBody>
@@ -12818,7 +12818,7 @@
         <p:spPr>
           <a:xfrm>
             <a:off x="7259576" y="5221224"/>
-            <a:ext cx="512064" cy="64008"/>
+            <a:ext cx="416052" cy="64008"/>
           </a:xfrm>
           <a:prstGeom prst="rect">
             <a:avLst/>
@@ -12934,7 +12934,7 @@
                 </a:solidFill>
                 <a:latin typeface="Bahnschrift"/>
               </a:rPr>
-              <a:t>80</a:t>
+              <a:t>65</a:t>
             </a:r>
           </a:p>
         </p:txBody>
@@ -13155,7 +13155,7 @@
                 </a:solidFill>
                 <a:latin typeface="Bahnschrift"/>
               </a:rPr>
-              <a:t>Ionic fund-quality framework · Direct-plan NAV vs total-return benchmark · structural watch-outs flagged per scheme. Illustrative synthetic funds.</a:t>
+              <a:t>Ionic fund-quality framework · Direct-plan NAV vs each scheme's own SEBI category benchmark (TRI) · structural watch-outs flagged per scheme. Illustrative synthetic funds.</a:t>
             </a:r>
           </a:p>
         </p:txBody>

</xml_diff>